<commit_message>
forgot to update slideshow
</commit_message>
<xml_diff>
--- a/final project/AI Presentation.pptx
+++ b/final project/AI Presentation.pptx
@@ -11,6 +11,7 @@
     <p:sldId id="259" r:id="rId5"/>
     <p:sldId id="260" r:id="rId6"/>
     <p:sldId id="261" r:id="rId7"/>
+    <p:sldId id="262" r:id="rId8"/>
   </p:sldIdLst>
   <p:sldSz cx="12192000" cy="6858000"/>
   <p:notesSz cx="6858000" cy="9144000"/>
@@ -120,7 +121,7 @@
 <file path=ppt/revisionInfo.xml><?xml version="1.0" encoding="utf-8"?>
 <p1510:revInfo xmlns:a="http://schemas.openxmlformats.org/drawingml/2006/main" xmlns:r="http://schemas.openxmlformats.org/officeDocument/2006/relationships" xmlns:p1510="http://schemas.microsoft.com/office/powerpoint/2015/10/main">
   <p1510:revLst>
-    <p1510:client id="{5B3A40F2-6170-ED07-9FCD-1B7247A5C21F}" v="11" dt="2025-12-11T18:03:37.150"/>
+    <p1510:client id="{5B3A40F2-6170-ED07-9FCD-1B7247A5C21F}" v="34" dt="2025-12-11T18:04:41.314"/>
     <p1510:client id="{A5DBE238-BAEC-4E1B-1194-959FC9506782}" v="817" dt="2025-12-11T01:19:03.589"/>
     <p1510:client id="{FC1BD509-3A03-9D27-A618-8BF6D39E2EB0}" v="2" dt="2025-12-11T18:00:56.732"/>
   </p1510:revLst>
@@ -256,7 +257,7 @@
           <a:p>
             <a:fld id="{846CE7D5-CF57-46EF-B807-FDD0502418D4}" type="datetimeFigureOut">
               <a:rPr lang="en-US" smtClean="0"/>
-              <a:t>12/11/2025</a:t>
+              <a:t>12/15/2025</a:t>
             </a:fld>
             <a:endParaRPr lang="en-US"/>
           </a:p>
@@ -424,7 +425,7 @@
           <a:p>
             <a:fld id="{846CE7D5-CF57-46EF-B807-FDD0502418D4}" type="datetimeFigureOut">
               <a:rPr lang="en-US" smtClean="0"/>
-              <a:t>12/11/2025</a:t>
+              <a:t>12/15/2025</a:t>
             </a:fld>
             <a:endParaRPr lang="en-US"/>
           </a:p>
@@ -602,7 +603,7 @@
           <a:p>
             <a:fld id="{846CE7D5-CF57-46EF-B807-FDD0502418D4}" type="datetimeFigureOut">
               <a:rPr lang="en-US" smtClean="0"/>
-              <a:t>12/11/2025</a:t>
+              <a:t>12/15/2025</a:t>
             </a:fld>
             <a:endParaRPr lang="en-US"/>
           </a:p>
@@ -770,7 +771,7 @@
           <a:p>
             <a:fld id="{846CE7D5-CF57-46EF-B807-FDD0502418D4}" type="datetimeFigureOut">
               <a:rPr lang="en-US" smtClean="0"/>
-              <a:t>12/11/2025</a:t>
+              <a:t>12/15/2025</a:t>
             </a:fld>
             <a:endParaRPr lang="en-US"/>
           </a:p>
@@ -1015,7 +1016,7 @@
           <a:p>
             <a:fld id="{846CE7D5-CF57-46EF-B807-FDD0502418D4}" type="datetimeFigureOut">
               <a:rPr lang="en-US" smtClean="0"/>
-              <a:t>12/11/2025</a:t>
+              <a:t>12/15/2025</a:t>
             </a:fld>
             <a:endParaRPr lang="en-US"/>
           </a:p>
@@ -1244,7 +1245,7 @@
           <a:p>
             <a:fld id="{846CE7D5-CF57-46EF-B807-FDD0502418D4}" type="datetimeFigureOut">
               <a:rPr lang="en-US" smtClean="0"/>
-              <a:t>12/11/2025</a:t>
+              <a:t>12/15/2025</a:t>
             </a:fld>
             <a:endParaRPr lang="en-US"/>
           </a:p>
@@ -1608,7 +1609,7 @@
           <a:p>
             <a:fld id="{846CE7D5-CF57-46EF-B807-FDD0502418D4}" type="datetimeFigureOut">
               <a:rPr lang="en-US" smtClean="0"/>
-              <a:t>12/11/2025</a:t>
+              <a:t>12/15/2025</a:t>
             </a:fld>
             <a:endParaRPr lang="en-US"/>
           </a:p>
@@ -1725,7 +1726,7 @@
           <a:p>
             <a:fld id="{846CE7D5-CF57-46EF-B807-FDD0502418D4}" type="datetimeFigureOut">
               <a:rPr lang="en-US" smtClean="0"/>
-              <a:t>12/11/2025</a:t>
+              <a:t>12/15/2025</a:t>
             </a:fld>
             <a:endParaRPr lang="en-US"/>
           </a:p>
@@ -1820,7 +1821,7 @@
           <a:p>
             <a:fld id="{846CE7D5-CF57-46EF-B807-FDD0502418D4}" type="datetimeFigureOut">
               <a:rPr lang="en-US" smtClean="0"/>
-              <a:t>12/11/2025</a:t>
+              <a:t>12/15/2025</a:t>
             </a:fld>
             <a:endParaRPr lang="en-US"/>
           </a:p>
@@ -2095,7 +2096,7 @@
           <a:p>
             <a:fld id="{846CE7D5-CF57-46EF-B807-FDD0502418D4}" type="datetimeFigureOut">
               <a:rPr lang="en-US" smtClean="0"/>
-              <a:t>12/11/2025</a:t>
+              <a:t>12/15/2025</a:t>
             </a:fld>
             <a:endParaRPr lang="en-US"/>
           </a:p>
@@ -2350,7 +2351,7 @@
           <a:p>
             <a:fld id="{846CE7D5-CF57-46EF-B807-FDD0502418D4}" type="datetimeFigureOut">
               <a:rPr lang="en-US" smtClean="0"/>
-              <a:t>12/11/2025</a:t>
+              <a:t>12/15/2025</a:t>
             </a:fld>
             <a:endParaRPr lang="en-US"/>
           </a:p>
@@ -2561,7 +2562,7 @@
           <a:p>
             <a:fld id="{846CE7D5-CF57-46EF-B807-FDD0502418D4}" type="datetimeFigureOut">
               <a:rPr lang="en-US" smtClean="0"/>
-              <a:t>12/11/2025</a:t>
+              <a:t>12/15/2025</a:t>
             </a:fld>
             <a:endParaRPr lang="en-US"/>
           </a:p>
@@ -3370,7 +3371,7 @@
           <a:lstStyle/>
           <a:p>
             <a:r>
-              <a:rPr lang="en-US" dirty="0"/>
+              <a:rPr lang="en-US"/>
               <a:t>Results</a:t>
             </a:r>
           </a:p>
@@ -3444,7 +3445,7 @@
               <a:buChar char="•"/>
             </a:pPr>
             <a:r>
-              <a:rPr lang="en-US" dirty="0"/>
+              <a:rPr lang="en-US"/>
               <a:t>Training Data</a:t>
             </a:r>
           </a:p>
@@ -3454,7 +3455,7 @@
               <a:buChar char="•"/>
             </a:pPr>
             <a:r>
-              <a:rPr lang="en-US" dirty="0"/>
+              <a:rPr lang="en-US"/>
               <a:t>Demo Video</a:t>
             </a:r>
           </a:p>
@@ -3973,6 +3974,100 @@
     <p:extLst>
       <p:ext uri="{BB962C8B-B14F-4D97-AF65-F5344CB8AC3E}">
         <p14:creationId xmlns:p14="http://schemas.microsoft.com/office/powerpoint/2010/main" val="737138484"/>
+      </p:ext>
+    </p:extLst>
+  </p:cSld>
+  <p:clrMapOvr>
+    <a:masterClrMapping/>
+  </p:clrMapOvr>
+</p:sld>
+</file>
+
+<file path=ppt/slides/slide7.xml><?xml version="1.0" encoding="utf-8"?>
+<p:sld xmlns:a="http://schemas.openxmlformats.org/drawingml/2006/main" xmlns:r="http://schemas.openxmlformats.org/officeDocument/2006/relationships" xmlns:p="http://schemas.openxmlformats.org/presentationml/2006/main">
+  <p:cSld>
+    <p:spTree>
+      <p:nvGrpSpPr>
+        <p:cNvPr id="1" name=""/>
+        <p:cNvGrpSpPr/>
+        <p:nvPr/>
+      </p:nvGrpSpPr>
+      <p:grpSpPr>
+        <a:xfrm>
+          <a:off x="0" y="0"/>
+          <a:ext cx="0" cy="0"/>
+          <a:chOff x="0" y="0"/>
+          <a:chExt cx="0" cy="0"/>
+        </a:xfrm>
+      </p:grpSpPr>
+      <p:sp>
+        <p:nvSpPr>
+          <p:cNvPr id="2" name="Title 1">
+            <a:extLst>
+              <a:ext uri="{FF2B5EF4-FFF2-40B4-BE49-F238E27FC236}">
+                <a16:creationId xmlns:a16="http://schemas.microsoft.com/office/drawing/2014/main" id="{80269CD8-E9B1-879E-A258-A4F5CAA1BBE4}"/>
+              </a:ext>
+            </a:extLst>
+          </p:cNvPr>
+          <p:cNvSpPr>
+            <a:spLocks noGrp="1"/>
+          </p:cNvSpPr>
+          <p:nvPr>
+            <p:ph type="title"/>
+          </p:nvPr>
+        </p:nvSpPr>
+        <p:spPr/>
+        <p:txBody>
+          <a:bodyPr/>
+          <a:lstStyle/>
+          <a:p>
+            <a:r>
+              <a:rPr lang="en-US"/>
+              <a:t>Future Work</a:t>
+            </a:r>
+          </a:p>
+        </p:txBody>
+      </p:sp>
+      <p:sp>
+        <p:nvSpPr>
+          <p:cNvPr id="3" name="Content Placeholder 2">
+            <a:extLst>
+              <a:ext uri="{FF2B5EF4-FFF2-40B4-BE49-F238E27FC236}">
+                <a16:creationId xmlns:a16="http://schemas.microsoft.com/office/drawing/2014/main" id="{D6C5DF03-D12C-7C3A-6E0D-37C66C49620A}"/>
+              </a:ext>
+            </a:extLst>
+          </p:cNvPr>
+          <p:cNvSpPr>
+            <a:spLocks noGrp="1"/>
+          </p:cNvSpPr>
+          <p:nvPr>
+            <p:ph idx="1"/>
+          </p:nvPr>
+        </p:nvSpPr>
+        <p:spPr/>
+        <p:txBody>
+          <a:bodyPr vert="horz" lIns="91440" tIns="45720" rIns="91440" bIns="45720" rtlCol="0" anchor="t">
+            <a:normAutofit/>
+          </a:bodyPr>
+          <a:lstStyle/>
+          <a:p>
+            <a:r>
+              <a:rPr lang="en-US"/>
+              <a:t>Debug the edge tracking</a:t>
+            </a:r>
+          </a:p>
+          <a:p>
+            <a:r>
+              <a:rPr lang="en-US"/>
+              <a:t>Accelerate the tracking</a:t>
+            </a:r>
+          </a:p>
+        </p:txBody>
+      </p:sp>
+    </p:spTree>
+    <p:extLst>
+      <p:ext uri="{BB962C8B-B14F-4D97-AF65-F5344CB8AC3E}">
+        <p14:creationId xmlns:p14="http://schemas.microsoft.com/office/powerpoint/2010/main" val="392027584"/>
       </p:ext>
     </p:extLst>
   </p:cSld>

</xml_diff>